<commit_message>
NeuroRedTeam deck v2: Flappy Bird side-result slides, hedged novelty wording, defender result on results slide
Co-Authored-By: Claude Opus 5 <noreply@anthropic.com>
</commit_message>
<xml_diff>
--- a/NeuroRedTeam_Phase1.pptx
+++ b/NeuroRedTeam_Phase1.pptx
@@ -19,6 +19,8 @@
     <p:sldId id="264" r:id="rId10"/>
     <p:sldId id="273" r:id="rId28"/>
     <p:sldId id="272" r:id="rId27"/>
+    <p:sldId id="275" r:id="rId30"/>
+    <p:sldId id="274" r:id="rId29"/>
     <p:sldId id="265" r:id="rId11"/>
     <p:sldId id="266" r:id="rId12"/>
     <p:sldId id="267" r:id="rId13"/>
@@ -15065,7 +15067,7 @@
             </a:r>
             <a:r>
               <a:rPr lang="en-IN" sz="1500"/>
-              <a:t>the real 139,255-neuron brain runs on a normal laptop and matches the Nature 2024 numbers; and the first entry of the fragility atlas already exists: feeding can be blocked with 3 neurons, but not with 10 random ones. The attacker agent's job is to find results like this automatically, for every behaviour, under rules.</a:t>
+              <a:t>the real brain runs on a laptop and matches Nature 2024. First atlas entry, done by hand: attack = cut 3 neurons, feeding drops from 85 to 1.7 Hz; repair = boost 6 surviving inputs (small bias plus x2 synapse strength), feeding returns to 42 Hz with sugar and stays at 0 Hz without sugar, so it is a real repair, not forcing. Simple repair moves failed; the combination worked, which is why the defender needs a search agent.</a:t>
             </a:r>
             <a:endParaRPr sz="1500"/>
           </a:p>
@@ -15458,11 +15460,11 @@
             </a:pPr>
             <a:r>
               <a:rPr lang="en-IN" sz="1300" b="1"/>
-              <a:t xml:space="preserve">December: </a:t>
+              <a:t xml:space="preserve">Repair, tested by hand: </a:t>
             </a:r>
             <a:r>
               <a:rPr lang="en-IN" sz="1300"/>
-              <a:t>press Attack and the agent finds this itself; press Defend and it finds the neurons to stimulate so the fly eats again.</a:t>
+              <a:t>boosting 6 surviving inputs brings feeding back to 42 Hz with sugar, 0 Hz without. Next two slides: the same brain playing Flappy Bird.</a:t>
             </a:r>
             <a:endParaRPr sz="1300"/>
           </a:p>
@@ -15615,6 +15617,1039 @@
 </file>
 
 <file path=ppt/slides/slide12.xml><?xml version="1.0" encoding="utf-8"?>
+<p:sld xmlns:a="http://schemas.openxmlformats.org/drawingml/2006/main" xmlns:r="http://schemas.openxmlformats.org/officeDocument/2006/relationships" xmlns:p="http://schemas.openxmlformats.org/presentationml/2006/main">
+  <p:cSld>
+    <p:spTree>
+      <p:nvGrpSpPr>
+        <p:cNvPr id="1" name="Shape 149"/>
+        <p:cNvGrpSpPr/>
+        <p:nvPr/>
+      </p:nvGrpSpPr>
+      <p:grpSpPr>
+        <a:xfrm>
+          <a:off x="0" y="0"/>
+          <a:ext cx="0" cy="0"/>
+          <a:chOff x="0" y="0"/>
+          <a:chExt cx="0" cy="0"/>
+        </a:xfrm>
+      </p:grpSpPr>
+      <p:sp>
+        <p:nvSpPr>
+          <p:cNvPr id="150" name="Google Shape;150;p5"/>
+          <p:cNvSpPr txBox="1">
+            <a:spLocks noGrp="1"/>
+          </p:cNvSpPr>
+          <p:nvPr>
+            <p:ph type="body" idx="1"/>
+          </p:nvPr>
+        </p:nvSpPr>
+        <p:spPr>
+          <a:xfrm>
+            <a:off x="6400800" y="1097280"/>
+            <a:ext cx="5577840" cy="5120640"/>
+          </a:xfrm>
+          <a:prstGeom prst="rect">
+            <a:avLst/>
+          </a:prstGeom>
+          <a:noFill/>
+          <a:ln>
+            <a:noFill/>
+          </a:ln>
+        </p:spPr>
+        <p:txBody>
+          <a:bodyPr spcFirstLastPara="1" wrap="square" lIns="91425" tIns="45700" rIns="91425" bIns="45700" anchor="t" anchorCtr="0">
+            <a:noAutofit/>
+          </a:bodyPr>
+          <a:lstStyle/>
+          <a:p>
+            <a:pPr marL="228600" lvl="0" indent="-228600" algn="l" rtl="0">
+              <a:lnSpc>
+                <a:spcPct val="90000"/>
+              </a:lnSpc>
+              <a:spcBef>
+                <a:spcPts val="0"/>
+              </a:spcBef>
+              <a:spcAft>
+                <a:spcPts val="0"/>
+              </a:spcAft>
+              <a:buClr>
+                <a:srgbClr val="002060"/>
+              </a:buClr>
+              <a:buSzPts val="2800"/>
+              <a:buChar char="•"/>
+            </a:pPr>
+            <a:r>
+              <a:rPr lang="en-IN" sz="1300" b="1"/>
+              <a:t xml:space="preserve">Why we did it: </a:t>
+            </a:r>
+            <a:r>
+              <a:rPr lang="en-IN" sz="1300"/>
+              <a:t>to check that the fly's wiring works as a neural network before building agents on it.</a:t>
+            </a:r>
+            <a:endParaRPr sz="1300"/>
+          </a:p>
+          <a:p>
+            <a:pPr marL="228600" lvl="0" indent="-228600" algn="l" rtl="0">
+              <a:lnSpc>
+                <a:spcPct val="90000"/>
+              </a:lnSpc>
+              <a:spcBef>
+                <a:spcPts val="1000"/>
+              </a:spcBef>
+              <a:spcAft>
+                <a:spcPts val="0"/>
+              </a:spcAft>
+              <a:buClr>
+                <a:srgbClr val="002060"/>
+              </a:buClr>
+              <a:buSzPts val="2800"/>
+              <a:buChar char="•"/>
+            </a:pPr>
+            <a:r>
+              <a:rPr lang="en-IN" sz="1300" b="1"/>
+              <a:t xml:space="preserve">The brain part: </a:t>
+            </a:r>
+            <a:r>
+              <a:rPr lang="en-IN" sz="1300"/>
+              <a:t>we took 3,000 real neurons and their 241,219 real connections (with the excitatory or inhibitory sign kept) and used them unchanged. Nothing about pipes or jumping is programmed.</a:t>
+            </a:r>
+            <a:endParaRPr sz="1300"/>
+          </a:p>
+          <a:p>
+            <a:pPr marL="228600" lvl="0" indent="-228600" algn="l" rtl="0">
+              <a:lnSpc>
+                <a:spcPct val="90000"/>
+              </a:lnSpc>
+              <a:spcBef>
+                <a:spcPts val="1000"/>
+              </a:spcBef>
+              <a:spcAft>
+                <a:spcPts val="0"/>
+              </a:spcAft>
+              <a:buClr>
+                <a:srgbClr val="002060"/>
+              </a:buClr>
+              <a:buSzPts val="2800"/>
+              <a:buChar char="•"/>
+            </a:pPr>
+            <a:r>
+              <a:rPr lang="en-IN" sz="1300" b="1"/>
+              <a:t xml:space="preserve">What it sees: </a:t>
+            </a:r>
+            <a:r>
+              <a:rPr lang="en-IN" sz="1300"/>
+              <a:t>34 on/off signals each frame: my height, the gap's height, distance to the pipe. No velocity, so the brain has to remember previous frames.</a:t>
+            </a:r>
+            <a:endParaRPr sz="1300"/>
+          </a:p>
+          <a:p>
+            <a:pPr marL="228600" lvl="0" indent="-228600" algn="l" rtl="0">
+              <a:lnSpc>
+                <a:spcPct val="90000"/>
+              </a:lnSpc>
+              <a:spcBef>
+                <a:spcPts val="1000"/>
+              </a:spcBef>
+              <a:spcAft>
+                <a:spcPts val="0"/>
+              </a:spcAft>
+              <a:buClr>
+                <a:srgbClr val="002060"/>
+              </a:buClr>
+              <a:buSzPts val="2800"/>
+              <a:buChar char="•"/>
+            </a:pPr>
+            <a:r>
+              <a:rPr lang="en-IN" sz="1300" b="1"/>
+              <a:t xml:space="preserve">What we trained: </a:t>
+            </a:r>
+            <a:r>
+              <a:rPr lang="en-IN" sz="1300"/>
+              <a:t>only one output layer of 3,001 numbers that reads the 3,000 neuron activities and says flap or not. We fitted it by watching a simple rule-based coach play, then let the brain play and corrected its own mistakes (a standard method called imitation learning with DAgger).</a:t>
+            </a:r>
+            <a:endParaRPr sz="1300"/>
+          </a:p>
+          <a:p>
+            <a:pPr marL="228600" lvl="0" indent="-228600" algn="l" rtl="0">
+              <a:lnSpc>
+                <a:spcPct val="90000"/>
+              </a:lnSpc>
+              <a:spcBef>
+                <a:spcPts val="1000"/>
+              </a:spcBef>
+              <a:spcAft>
+                <a:spcPts val="0"/>
+              </a:spcAft>
+              <a:buClr>
+                <a:srgbClr val="002060"/>
+              </a:buClr>
+              <a:buSzPts val="2800"/>
+              <a:buChar char="•"/>
+            </a:pPr>
+            <a:r>
+              <a:rPr lang="en-IN" sz="1300" b="1"/>
+              <a:t xml:space="preserve">Then it plays alone. </a:t>
+            </a:r>
+            <a:r>
+              <a:rPr lang="en-IN" sz="1300"/>
+              <a:t>Press a key and the wiring is scrambled, or 300 neurons are cut, while it plays.</a:t>
+            </a:r>
+            <a:endParaRPr sz="1300"/>
+          </a:p>
+        </p:txBody>
+      </p:sp>
+      <p:sp>
+        <p:nvSpPr>
+          <p:cNvPr id="152" name="Google Shape;152;p5"/>
+          <p:cNvSpPr txBox="1">
+            <a:spLocks noGrp="1"/>
+          </p:cNvSpPr>
+          <p:nvPr>
+            <p:ph type="sldNum" idx="12"/>
+          </p:nvPr>
+        </p:nvSpPr>
+        <p:spPr>
+          <a:xfrm>
+            <a:off x="9273988" y="6347205"/>
+            <a:ext cx="2743200" cy="365125"/>
+          </a:xfrm>
+          <a:prstGeom prst="rect">
+            <a:avLst/>
+          </a:prstGeom>
+          <a:noFill/>
+          <a:ln>
+            <a:noFill/>
+          </a:ln>
+        </p:spPr>
+        <p:txBody>
+          <a:bodyPr spcFirstLastPara="1" wrap="square" lIns="91425" tIns="45700" rIns="91425" bIns="45700" anchor="ctr" anchorCtr="0">
+            <a:noAutofit/>
+          </a:bodyPr>
+          <a:lstStyle/>
+          <a:p>
+            <a:pPr marL="0" lvl="0" indent="0" algn="r" rtl="0">
+              <a:spcBef>
+                <a:spcPts val="0"/>
+              </a:spcBef>
+              <a:spcAft>
+                <a:spcPts val="0"/>
+              </a:spcAft>
+              <a:buNone/>
+            </a:pPr>
+            <a:r>
+              <a:rPr lang="en-IN"/>
+              <a:t/>
+            </a:r>
+            <a:fld id="{00000000-1234-1234-1234-123412341234}" type="slidenum">
+              <a:rPr lang="en-IN"/>
+              <a:t>12</a:t>
+            </a:fld>
+            <a:endParaRPr/>
+          </a:p>
+        </p:txBody>
+      </p:sp>
+      <p:sp>
+        <p:nvSpPr>
+          <p:cNvPr id="153" name="Google Shape;153;p5"/>
+          <p:cNvSpPr txBox="1"/>
+          <p:nvPr/>
+        </p:nvSpPr>
+        <p:spPr>
+          <a:xfrm>
+            <a:off x="1386895" y="145670"/>
+            <a:ext cx="9834426" cy="839401"/>
+          </a:xfrm>
+          <a:prstGeom prst="rect">
+            <a:avLst/>
+          </a:prstGeom>
+          <a:noFill/>
+          <a:ln w="9525" cap="flat" cmpd="sng">
+            <a:solidFill>
+              <a:schemeClr val="lt1"/>
+            </a:solidFill>
+            <a:prstDash val="dash"/>
+            <a:miter lim="800000"/>
+            <a:headEnd type="none" w="sm" len="sm"/>
+            <a:tailEnd type="none" w="sm" len="sm"/>
+          </a:ln>
+        </p:spPr>
+        <p:txBody>
+          <a:bodyPr spcFirstLastPara="1" wrap="square" lIns="91425" tIns="45700" rIns="91425" bIns="45700" anchor="ctr" anchorCtr="0">
+            <a:noAutofit/>
+          </a:bodyPr>
+          <a:lstStyle/>
+          <a:p>
+            <a:pPr marL="0" marR="0" lvl="0" indent="0" algn="ctr" rtl="0">
+              <a:spcBef>
+                <a:spcPts val="0"/>
+              </a:spcBef>
+              <a:spcAft>
+                <a:spcPts val="0"/>
+              </a:spcAft>
+              <a:buNone/>
+            </a:pPr>
+            <a:r>
+              <a:rPr lang="en-IN" sz="4000" b="1">
+                <a:solidFill>
+                  <a:srgbClr val="C00000"/>
+                </a:solidFill>
+                <a:latin typeface="Bookman Old Style"/>
+                <a:ea typeface="Bookman Old Style"/>
+                <a:cs typeface="Bookman Old Style"/>
+                <a:sym typeface="Bookman Old Style"/>
+              </a:rPr>
+              <a:t>Side Result: Flappy Bird</a:t>
+            </a:r>
+            <a:endParaRPr sz="4000" b="1">
+              <a:solidFill>
+                <a:srgbClr val="C00000"/>
+              </a:solidFill>
+              <a:latin typeface="Bookman Old Style"/>
+              <a:ea typeface="Bookman Old Style"/>
+              <a:cs typeface="Bookman Old Style"/>
+              <a:sym typeface="Bookman Old Style"/>
+            </a:endParaRPr>
+          </a:p>
+        </p:txBody>
+      </p:sp>
+      <p:pic>
+        <p:nvPicPr>
+          <p:cNvPr id="154" name="Picture 153" descr="flappy_frame.png"/>
+          <p:cNvPicPr>
+            <a:picLocks noChangeAspect="1"/>
+          </p:cNvPicPr>
+          <p:nvPr/>
+        </p:nvPicPr>
+        <p:blipFill>
+          <a:blip r:embed="rId2"/>
+          <a:stretch>
+            <a:fillRect/>
+          </a:stretch>
+        </p:blipFill>
+        <p:spPr>
+          <a:xfrm>
+            <a:off x="411480" y="1143000"/>
+            <a:ext cx="5760720" cy="2880360"/>
+          </a:xfrm>
+          <a:prstGeom prst="rect">
+            <a:avLst/>
+          </a:prstGeom>
+        </p:spPr>
+      </p:pic>
+      <p:sp>
+        <p:nvSpPr>
+          <p:cNvPr id="155" name="TextBox 154"/>
+          <p:cNvSpPr txBox="1"/>
+          <p:nvPr/>
+        </p:nvSpPr>
+        <p:spPr>
+          <a:xfrm>
+            <a:off x="411480" y="4480560"/>
+            <a:ext cx="5760720" cy="457200"/>
+          </a:xfrm>
+          <a:prstGeom prst="rect">
+            <a:avLst/>
+          </a:prstGeom>
+          <a:noFill/>
+        </p:spPr>
+        <p:txBody>
+          <a:bodyPr wrap="square">
+            <a:spAutoFit/>
+          </a:bodyPr>
+          <a:lstStyle/>
+          <a:p>
+            <a:pPr algn="ctr"/>
+            <a:r>
+              <a:rPr sz="1100">
+                <a:solidFill>
+                  <a:srgbClr val="002060"/>
+                </a:solidFill>
+                <a:latin typeface="Bookman Old Style"/>
+              </a:rPr>
+              <a:t>Left: the game. Right: 3,000 real fly neurons, brightness = activity. Runs live in a window.</a:t>
+            </a:r>
+          </a:p>
+        </p:txBody>
+      </p:sp>
+    </p:spTree>
+  </p:cSld>
+  <p:clrMapOvr>
+    <a:masterClrMapping/>
+  </p:clrMapOvr>
+</p:sld>
+</file>
+
+<file path=ppt/slides/slide13.xml><?xml version="1.0" encoding="utf-8"?>
+<p:sld xmlns:a="http://schemas.openxmlformats.org/drawingml/2006/main" xmlns:r="http://schemas.openxmlformats.org/officeDocument/2006/relationships" xmlns:p="http://schemas.openxmlformats.org/presentationml/2006/main">
+  <p:cSld>
+    <p:spTree>
+      <p:nvGrpSpPr>
+        <p:cNvPr id="1" name="Shape 149"/>
+        <p:cNvGrpSpPr/>
+        <p:nvPr/>
+      </p:nvGrpSpPr>
+      <p:grpSpPr>
+        <a:xfrm>
+          <a:off x="0" y="0"/>
+          <a:ext cx="0" cy="0"/>
+          <a:chOff x="0" y="0"/>
+          <a:chExt cx="0" cy="0"/>
+        </a:xfrm>
+      </p:grpSpPr>
+      <p:sp>
+        <p:nvSpPr>
+          <p:cNvPr id="150" name="Google Shape;150;p5"/>
+          <p:cNvSpPr txBox="1">
+            <a:spLocks noGrp="1"/>
+          </p:cNvSpPr>
+          <p:nvPr>
+            <p:ph type="body" idx="1"/>
+          </p:nvPr>
+        </p:nvSpPr>
+        <p:spPr>
+          <a:xfrm>
+            <a:off x="174813" y="3246120"/>
+            <a:ext cx="11842377" cy="3017520"/>
+          </a:xfrm>
+          <a:prstGeom prst="rect">
+            <a:avLst/>
+          </a:prstGeom>
+          <a:noFill/>
+          <a:ln>
+            <a:noFill/>
+          </a:ln>
+        </p:spPr>
+        <p:txBody>
+          <a:bodyPr spcFirstLastPara="1" wrap="square" lIns="91425" tIns="45700" rIns="91425" bIns="45700" anchor="t" anchorCtr="0">
+            <a:noAutofit/>
+          </a:bodyPr>
+          <a:lstStyle/>
+          <a:p>
+            <a:pPr marL="228600" lvl="0" indent="-228600" algn="l" rtl="0">
+              <a:lnSpc>
+                <a:spcPct val="90000"/>
+              </a:lnSpc>
+              <a:spcBef>
+                <a:spcPts val="0"/>
+              </a:spcBef>
+              <a:spcAft>
+                <a:spcPts val="0"/>
+              </a:spcAft>
+              <a:buClr>
+                <a:srgbClr val="002060"/>
+              </a:buClr>
+              <a:buSzPts val="2800"/>
+              <a:buChar char="•"/>
+            </a:pPr>
+            <a:r>
+              <a:rPr lang="en-IN" sz="1400" b="1"/>
+              <a:t xml:space="preserve">What worked: </a:t>
+            </a:r>
+            <a:r>
+              <a:rPr lang="en-IN" sz="1400"/>
+              <a:t>a real brain's wiring runs as a neural network and plays a game. When the game needs memory, having the recurrent brain beats having none by 3 to 10 times.</a:t>
+            </a:r>
+            <a:endParaRPr sz="1400"/>
+          </a:p>
+          <a:p>
+            <a:pPr marL="228600" lvl="0" indent="-228600" algn="l" rtl="0">
+              <a:lnSpc>
+                <a:spcPct val="90000"/>
+              </a:lnSpc>
+              <a:spcBef>
+                <a:spcPts val="1000"/>
+              </a:spcBef>
+              <a:spcAft>
+                <a:spcPts val="0"/>
+              </a:spcAft>
+              <a:buClr>
+                <a:srgbClr val="002060"/>
+              </a:buClr>
+              <a:buSzPts val="2800"/>
+              <a:buChar char="•"/>
+            </a:pPr>
+            <a:r>
+              <a:rPr lang="en-IN" sz="1400" b="1"/>
+              <a:t xml:space="preserve">What did not work, and we say so: </a:t>
+            </a:r>
+            <a:r>
+              <a:rPr lang="en-IN" sz="1400"/>
+              <a:t>the fly's exact wiring did not beat the same neurons with scrambled wiring. It tied, and with slower neurons it lost. This matches two 2024 to 2026 papers (Suarez et al.; Dhiman) which found no clear advantage for the fly wiring in this kind of simplified network. We do not claim one.</a:t>
+            </a:r>
+            <a:endParaRPr sz="1400"/>
+          </a:p>
+          <a:p>
+            <a:pPr marL="228600" lvl="0" indent="-228600" algn="l" rtl="0">
+              <a:lnSpc>
+                <a:spcPct val="90000"/>
+              </a:lnSpc>
+              <a:spcBef>
+                <a:spcPts val="1000"/>
+              </a:spcBef>
+              <a:spcAft>
+                <a:spcPts val="0"/>
+              </a:spcAft>
+              <a:buClr>
+                <a:srgbClr val="002060"/>
+              </a:buClr>
+              <a:buSzPts val="2800"/>
+              <a:buChar char="•"/>
+            </a:pPr>
+            <a:r>
+              <a:rPr lang="en-IN" sz="1400" b="1"/>
+              <a:t xml:space="preserve">Why this shaped the project: </a:t>
+            </a:r>
+            <a:r>
+              <a:rPr lang="en-IN" sz="1400"/>
+              <a:t>it showed us the platform works, and it showed that "is nature's wiring better?" is a crowded and disputed question. So we moved the project to a question we could not find answered anywhere: how fragile is each behaviour, and how do you repair it.</a:t>
+            </a:r>
+            <a:endParaRPr sz="1400"/>
+          </a:p>
+        </p:txBody>
+      </p:sp>
+      <p:sp>
+        <p:nvSpPr>
+          <p:cNvPr id="152" name="Google Shape;152;p5"/>
+          <p:cNvSpPr txBox="1">
+            <a:spLocks noGrp="1"/>
+          </p:cNvSpPr>
+          <p:nvPr>
+            <p:ph type="sldNum" idx="12"/>
+          </p:nvPr>
+        </p:nvSpPr>
+        <p:spPr>
+          <a:xfrm>
+            <a:off x="9273988" y="6347205"/>
+            <a:ext cx="2743200" cy="365125"/>
+          </a:xfrm>
+          <a:prstGeom prst="rect">
+            <a:avLst/>
+          </a:prstGeom>
+          <a:noFill/>
+          <a:ln>
+            <a:noFill/>
+          </a:ln>
+        </p:spPr>
+        <p:txBody>
+          <a:bodyPr spcFirstLastPara="1" wrap="square" lIns="91425" tIns="45700" rIns="91425" bIns="45700" anchor="ctr" anchorCtr="0">
+            <a:noAutofit/>
+          </a:bodyPr>
+          <a:lstStyle/>
+          <a:p>
+            <a:pPr marL="0" lvl="0" indent="0" algn="r" rtl="0">
+              <a:spcBef>
+                <a:spcPts val="0"/>
+              </a:spcBef>
+              <a:spcAft>
+                <a:spcPts val="0"/>
+              </a:spcAft>
+              <a:buNone/>
+            </a:pPr>
+            <a:r>
+              <a:rPr lang="en-IN"/>
+              <a:t/>
+            </a:r>
+            <a:fld id="{00000000-1234-1234-1234-123412341234}" type="slidenum">
+              <a:rPr lang="en-IN"/>
+              <a:t>13</a:t>
+            </a:fld>
+            <a:endParaRPr/>
+          </a:p>
+        </p:txBody>
+      </p:sp>
+      <p:sp>
+        <p:nvSpPr>
+          <p:cNvPr id="153" name="Google Shape;153;p5"/>
+          <p:cNvSpPr txBox="1"/>
+          <p:nvPr/>
+        </p:nvSpPr>
+        <p:spPr>
+          <a:xfrm>
+            <a:off x="1386895" y="145670"/>
+            <a:ext cx="9834426" cy="839401"/>
+          </a:xfrm>
+          <a:prstGeom prst="rect">
+            <a:avLst/>
+          </a:prstGeom>
+          <a:noFill/>
+          <a:ln w="9525" cap="flat" cmpd="sng">
+            <a:solidFill>
+              <a:schemeClr val="lt1"/>
+            </a:solidFill>
+            <a:prstDash val="dash"/>
+            <a:miter lim="800000"/>
+            <a:headEnd type="none" w="sm" len="sm"/>
+            <a:tailEnd type="none" w="sm" len="sm"/>
+          </a:ln>
+        </p:spPr>
+        <p:txBody>
+          <a:bodyPr spcFirstLastPara="1" wrap="square" lIns="91425" tIns="45700" rIns="91425" bIns="45700" anchor="ctr" anchorCtr="0">
+            <a:noAutofit/>
+          </a:bodyPr>
+          <a:lstStyle/>
+          <a:p>
+            <a:pPr marL="0" marR="0" lvl="0" indent="0" algn="ctr" rtl="0">
+              <a:spcBef>
+                <a:spcPts val="0"/>
+              </a:spcBef>
+              <a:spcAft>
+                <a:spcPts val="0"/>
+              </a:spcAft>
+              <a:buNone/>
+            </a:pPr>
+            <a:r>
+              <a:rPr lang="en-IN" sz="4000" b="1">
+                <a:solidFill>
+                  <a:srgbClr val="C00000"/>
+                </a:solidFill>
+                <a:latin typeface="Bookman Old Style"/>
+                <a:ea typeface="Bookman Old Style"/>
+                <a:cs typeface="Bookman Old Style"/>
+                <a:sym typeface="Bookman Old Style"/>
+              </a:rPr>
+              <a:t>Flappy Bird: Honest Results</a:t>
+            </a:r>
+            <a:endParaRPr sz="4000" b="1">
+              <a:solidFill>
+                <a:srgbClr val="C00000"/>
+              </a:solidFill>
+              <a:latin typeface="Bookman Old Style"/>
+              <a:ea typeface="Bookman Old Style"/>
+              <a:cs typeface="Bookman Old Style"/>
+              <a:sym typeface="Bookman Old Style"/>
+            </a:endParaRPr>
+          </a:p>
+        </p:txBody>
+      </p:sp>
+      <p:graphicFrame>
+        <p:nvGraphicFramePr>
+          <p:cNvPr id="154" name="Table 153"/>
+          <p:cNvGraphicFramePr>
+            <a:graphicFrameLocks noGrp="1"/>
+          </p:cNvGraphicFramePr>
+          <p:nvPr/>
+        </p:nvGraphicFramePr>
+        <p:xfrm>
+          <a:off x="457200" y="1188720"/>
+          <a:ext cx="11247120" cy="1828800"/>
+        </p:xfrm>
+        <a:graphic>
+          <a:graphicData uri="http://schemas.openxmlformats.org/drawingml/2006/table">
+            <a:tbl>
+              <a:tblPr firstRow="1" bandRow="1">
+                <a:tableStyleId>{5C22544A-7EE6-4342-B048-85BDC9FD1C3A}</a:tableStyleId>
+              </a:tblPr>
+              <a:tblGrid>
+                <a:gridCol w="4114800"/>
+                <a:gridCol w="2377440"/>
+                <a:gridCol w="2377440"/>
+                <a:gridCol w="2377440"/>
+              </a:tblGrid>
+              <a:tr h="457200">
+                <a:tc>
+                  <a:txBody>
+                    <a:bodyPr/>
+                    <a:lstStyle/>
+                    <a:p>
+                      <a:pPr>
+                        <a:defRPr sz="1300" b="1">
+                          <a:solidFill>
+                            <a:srgbClr val="FFFFFF"/>
+                          </a:solidFill>
+                          <a:latin typeface="Bookman Old Style"/>
+                        </a:defRPr>
+                      </a:pPr>
+                      <a:r>
+                        <a:t>Game version</a:t>
+                      </a:r>
+                    </a:p>
+                  </a:txBody>
+                  <a:tcPr>
+                    <a:solidFill>
+                      <a:srgbClr val="002060"/>
+                    </a:solidFill>
+                  </a:tcPr>
+                </a:tc>
+                <a:tc>
+                  <a:txBody>
+                    <a:bodyPr/>
+                    <a:lstStyle/>
+                    <a:p>
+                      <a:pPr>
+                        <a:defRPr sz="1300" b="1">
+                          <a:solidFill>
+                            <a:srgbClr val="FFFFFF"/>
+                          </a:solidFill>
+                          <a:latin typeface="Bookman Old Style"/>
+                        </a:defRPr>
+                      </a:pPr>
+                      <a:r>
+                        <a:t>Fly brain (real wiring)</a:t>
+                      </a:r>
+                    </a:p>
+                  </a:txBody>
+                  <a:tcPr>
+                    <a:solidFill>
+                      <a:srgbClr val="002060"/>
+                    </a:solidFill>
+                  </a:tcPr>
+                </a:tc>
+                <a:tc>
+                  <a:txBody>
+                    <a:bodyPr/>
+                    <a:lstStyle/>
+                    <a:p>
+                      <a:pPr>
+                        <a:defRPr sz="1300" b="1">
+                          <a:solidFill>
+                            <a:srgbClr val="FFFFFF"/>
+                          </a:solidFill>
+                          <a:latin typeface="Bookman Old Style"/>
+                        </a:defRPr>
+                      </a:pPr>
+                      <a:r>
+                        <a:t>Same neurons, wiring scrambled</a:t>
+                      </a:r>
+                    </a:p>
+                  </a:txBody>
+                  <a:tcPr>
+                    <a:solidFill>
+                      <a:srgbClr val="002060"/>
+                    </a:solidFill>
+                  </a:tcPr>
+                </a:tc>
+                <a:tc>
+                  <a:txBody>
+                    <a:bodyPr/>
+                    <a:lstStyle/>
+                    <a:p>
+                      <a:pPr>
+                        <a:defRPr sz="1300" b="1">
+                          <a:solidFill>
+                            <a:srgbClr val="FFFFFF"/>
+                          </a:solidFill>
+                          <a:latin typeface="Bookman Old Style"/>
+                        </a:defRPr>
+                      </a:pPr>
+                      <a:r>
+                        <a:t>No brain (plain output layer)</a:t>
+                      </a:r>
+                    </a:p>
+                  </a:txBody>
+                  <a:tcPr>
+                    <a:solidFill>
+                      <a:srgbClr val="002060"/>
+                    </a:solidFill>
+                  </a:tcPr>
+                </a:tc>
+              </a:tr>
+              <a:tr h="457200">
+                <a:tc>
+                  <a:txBody>
+                    <a:bodyPr/>
+                    <a:lstStyle/>
+                    <a:p>
+                      <a:pPr>
+                        <a:defRPr sz="1300" b="1">
+                          <a:solidFill>
+                            <a:srgbClr val="002060"/>
+                          </a:solidFill>
+                          <a:latin typeface="Bookman Old Style"/>
+                        </a:defRPr>
+                      </a:pPr>
+                      <a:r>
+                        <a:t>Normal game (100 games)</a:t>
+                      </a:r>
+                    </a:p>
+                  </a:txBody>
+                  <a:tcPr>
+                    <a:solidFill>
+                      <a:srgbClr val="F2F5FA"/>
+                    </a:solidFill>
+                  </a:tcPr>
+                </a:tc>
+                <a:tc>
+                  <a:txBody>
+                    <a:bodyPr/>
+                    <a:lstStyle/>
+                    <a:p>
+                      <a:pPr>
+                        <a:defRPr sz="1300" b="0">
+                          <a:solidFill>
+                            <a:srgbClr val="002060"/>
+                          </a:solidFill>
+                          <a:latin typeface="Bookman Old Style"/>
+                        </a:defRPr>
+                      </a:pPr>
+                      <a:r>
+                        <a:t>25 pipes</a:t>
+                      </a:r>
+                    </a:p>
+                  </a:txBody>
+                  <a:tcPr>
+                    <a:solidFill>
+                      <a:srgbClr val="F2F5FA"/>
+                    </a:solidFill>
+                  </a:tcPr>
+                </a:tc>
+                <a:tc>
+                  <a:txBody>
+                    <a:bodyPr/>
+                    <a:lstStyle/>
+                    <a:p>
+                      <a:pPr>
+                        <a:defRPr sz="1300" b="0">
+                          <a:solidFill>
+                            <a:srgbClr val="002060"/>
+                          </a:solidFill>
+                          <a:latin typeface="Bookman Old Style"/>
+                        </a:defRPr>
+                      </a:pPr>
+                      <a:r>
+                        <a:t>20 pipes</a:t>
+                      </a:r>
+                    </a:p>
+                  </a:txBody>
+                  <a:tcPr>
+                    <a:solidFill>
+                      <a:srgbClr val="F2F5FA"/>
+                    </a:solidFill>
+                  </a:tcPr>
+                </a:tc>
+                <a:tc>
+                  <a:txBody>
+                    <a:bodyPr/>
+                    <a:lstStyle/>
+                    <a:p>
+                      <a:pPr>
+                        <a:defRPr sz="1300" b="0">
+                          <a:solidFill>
+                            <a:srgbClr val="002060"/>
+                          </a:solidFill>
+                          <a:latin typeface="Bookman Old Style"/>
+                        </a:defRPr>
+                      </a:pPr>
+                      <a:r>
+                        <a:t>37 pipes</a:t>
+                      </a:r>
+                    </a:p>
+                  </a:txBody>
+                  <a:tcPr>
+                    <a:solidFill>
+                      <a:srgbClr val="F2F5FA"/>
+                    </a:solidFill>
+                  </a:tcPr>
+                </a:tc>
+              </a:tr>
+              <a:tr h="457200">
+                <a:tc>
+                  <a:txBody>
+                    <a:bodyPr/>
+                    <a:lstStyle/>
+                    <a:p>
+                      <a:pPr>
+                        <a:defRPr sz="1300" b="1">
+                          <a:solidFill>
+                            <a:srgbClr val="002060"/>
+                          </a:solidFill>
+                          <a:latin typeface="Bookman Old Style"/>
+                        </a:defRPr>
+                      </a:pPr>
+                      <a:r>
+                        <a:t>Pipe hidden when close, needs memory (100 games)</a:t>
+                      </a:r>
+                    </a:p>
+                  </a:txBody>
+                  <a:tcPr>
+                    <a:solidFill>
+                      <a:srgbClr val="F2F5FA"/>
+                    </a:solidFill>
+                  </a:tcPr>
+                </a:tc>
+                <a:tc>
+                  <a:txBody>
+                    <a:bodyPr/>
+                    <a:lstStyle/>
+                    <a:p>
+                      <a:pPr>
+                        <a:defRPr sz="1300" b="0">
+                          <a:solidFill>
+                            <a:srgbClr val="002060"/>
+                          </a:solidFill>
+                          <a:latin typeface="Bookman Old Style"/>
+                        </a:defRPr>
+                      </a:pPr>
+                      <a:r>
+                        <a:t>3 pipes</a:t>
+                      </a:r>
+                    </a:p>
+                  </a:txBody>
+                  <a:tcPr>
+                    <a:solidFill>
+                      <a:srgbClr val="F2F5FA"/>
+                    </a:solidFill>
+                  </a:tcPr>
+                </a:tc>
+                <a:tc>
+                  <a:txBody>
+                    <a:bodyPr/>
+                    <a:lstStyle/>
+                    <a:p>
+                      <a:pPr>
+                        <a:defRPr sz="1300" b="0">
+                          <a:solidFill>
+                            <a:srgbClr val="002060"/>
+                          </a:solidFill>
+                          <a:latin typeface="Bookman Old Style"/>
+                        </a:defRPr>
+                      </a:pPr>
+                      <a:r>
+                        <a:t>3 pipes</a:t>
+                      </a:r>
+                    </a:p>
+                  </a:txBody>
+                  <a:tcPr>
+                    <a:solidFill>
+                      <a:srgbClr val="F2F5FA"/>
+                    </a:solidFill>
+                  </a:tcPr>
+                </a:tc>
+                <a:tc>
+                  <a:txBody>
+                    <a:bodyPr/>
+                    <a:lstStyle/>
+                    <a:p>
+                      <a:pPr>
+                        <a:defRPr sz="1300" b="0">
+                          <a:solidFill>
+                            <a:srgbClr val="002060"/>
+                          </a:solidFill>
+                          <a:latin typeface="Bookman Old Style"/>
+                        </a:defRPr>
+                      </a:pPr>
+                      <a:r>
+                        <a:t>1 pipe</a:t>
+                      </a:r>
+                    </a:p>
+                  </a:txBody>
+                  <a:tcPr>
+                    <a:solidFill>
+                      <a:srgbClr val="F2F5FA"/>
+                    </a:solidFill>
+                  </a:tcPr>
+                </a:tc>
+              </a:tr>
+              <a:tr h="457200">
+                <a:tc>
+                  <a:txBody>
+                    <a:bodyPr/>
+                    <a:lstStyle/>
+                    <a:p>
+                      <a:pPr>
+                        <a:defRPr sz="1300" b="1">
+                          <a:solidFill>
+                            <a:srgbClr val="002060"/>
+                          </a:solidFill>
+                          <a:latin typeface="Bookman Old Style"/>
+                        </a:defRPr>
+                      </a:pPr>
+                      <a:r>
+                        <a:t>Same, with slower neurons (30 games)</a:t>
+                      </a:r>
+                    </a:p>
+                  </a:txBody>
+                  <a:tcPr>
+                    <a:solidFill>
+                      <a:srgbClr val="F2F5FA"/>
+                    </a:solidFill>
+                  </a:tcPr>
+                </a:tc>
+                <a:tc>
+                  <a:txBody>
+                    <a:bodyPr/>
+                    <a:lstStyle/>
+                    <a:p>
+                      <a:pPr>
+                        <a:defRPr sz="1300" b="0">
+                          <a:solidFill>
+                            <a:srgbClr val="002060"/>
+                          </a:solidFill>
+                          <a:latin typeface="Bookman Old Style"/>
+                        </a:defRPr>
+                      </a:pPr>
+                      <a:r>
+                        <a:t>6 pipes</a:t>
+                      </a:r>
+                    </a:p>
+                  </a:txBody>
+                  <a:tcPr>
+                    <a:solidFill>
+                      <a:srgbClr val="F2F5FA"/>
+                    </a:solidFill>
+                  </a:tcPr>
+                </a:tc>
+                <a:tc>
+                  <a:txBody>
+                    <a:bodyPr/>
+                    <a:lstStyle/>
+                    <a:p>
+                      <a:pPr>
+                        <a:defRPr sz="1300" b="0">
+                          <a:solidFill>
+                            <a:srgbClr val="002060"/>
+                          </a:solidFill>
+                          <a:latin typeface="Bookman Old Style"/>
+                        </a:defRPr>
+                      </a:pPr>
+                      <a:r>
+                        <a:t>11 pipes</a:t>
+                      </a:r>
+                    </a:p>
+                  </a:txBody>
+                  <a:tcPr>
+                    <a:solidFill>
+                      <a:srgbClr val="F2F5FA"/>
+                    </a:solidFill>
+                  </a:tcPr>
+                </a:tc>
+                <a:tc>
+                  <a:txBody>
+                    <a:bodyPr/>
+                    <a:lstStyle/>
+                    <a:p>
+                      <a:pPr>
+                        <a:defRPr sz="1300" b="0">
+                          <a:solidFill>
+                            <a:srgbClr val="002060"/>
+                          </a:solidFill>
+                          <a:latin typeface="Bookman Old Style"/>
+                        </a:defRPr>
+                      </a:pPr>
+                      <a:r>
+                        <a:t>about 1 pipe</a:t>
+                      </a:r>
+                    </a:p>
+                  </a:txBody>
+                  <a:tcPr>
+                    <a:solidFill>
+                      <a:srgbClr val="F2F5FA"/>
+                    </a:solidFill>
+                  </a:tcPr>
+                </a:tc>
+              </a:tr>
+            </a:tbl>
+          </a:graphicData>
+        </a:graphic>
+      </p:graphicFrame>
+    </p:spTree>
+  </p:cSld>
+  <p:clrMapOvr>
+    <a:masterClrMapping/>
+  </p:clrMapOvr>
+</p:sld>
+</file>
+
+<file path=ppt/slides/slide14.xml><?xml version="1.0" encoding="utf-8"?>
 <p:sld xmlns:a="http://schemas.openxmlformats.org/drawingml/2006/main" xmlns:r="http://schemas.openxmlformats.org/officeDocument/2006/relationships" xmlns:p="http://schemas.openxmlformats.org/presentationml/2006/main">
   <p:cSld>
     <p:spTree>
@@ -15683,21 +16718,21 @@
             <a:endParaRPr sz="1500"/>
           </a:p>
           <a:p>
-            <a:pPr marL="685800" lvl="1" indent="-228600" algn="l" rtl="0">
-              <a:lnSpc>
-                <a:spcPct val="90000"/>
-              </a:lnSpc>
-              <a:spcBef>
-                <a:spcPts val="500"/>
-              </a:spcBef>
-              <a:spcAft>
-                <a:spcPts val="0"/>
-              </a:spcAft>
-              <a:buClr>
-                <a:schemeClr val="dk1"/>
-              </a:buClr>
-              <a:buSzPct val="100000"/>
-              <a:buChar char="•"/>
+            <a:pPr marL="228600" lvl="0" indent="-50800" algn="l" rtl="0">
+              <a:lnSpc>
+                <a:spcPct val="90000"/>
+              </a:lnSpc>
+              <a:spcBef>
+                <a:spcPts val="1000"/>
+              </a:spcBef>
+              <a:spcAft>
+                <a:spcPts val="0"/>
+              </a:spcAft>
+              <a:buClr>
+                <a:srgbClr val="002060"/>
+              </a:buClr>
+              <a:buSzPts val="2800"/>
+              <a:buNone/>
             </a:pPr>
             <a:r>
               <a:rPr lang="en-IN" sz="1400"/>
@@ -15706,21 +16741,21 @@
             <a:endParaRPr sz="1400"/>
           </a:p>
           <a:p>
-            <a:pPr marL="685800" lvl="1" indent="-228600" algn="l" rtl="0">
-              <a:lnSpc>
-                <a:spcPct val="90000"/>
-              </a:lnSpc>
-              <a:spcBef>
-                <a:spcPts val="500"/>
-              </a:spcBef>
-              <a:spcAft>
-                <a:spcPts val="0"/>
-              </a:spcAft>
-              <a:buClr>
-                <a:schemeClr val="dk1"/>
-              </a:buClr>
-              <a:buSzPct val="100000"/>
-              <a:buChar char="•"/>
+            <a:pPr marL="228600" lvl="0" indent="-50800" algn="l" rtl="0">
+              <a:lnSpc>
+                <a:spcPct val="90000"/>
+              </a:lnSpc>
+              <a:spcBef>
+                <a:spcPts val="1000"/>
+              </a:spcBef>
+              <a:spcAft>
+                <a:spcPts val="0"/>
+              </a:spcAft>
+              <a:buClr>
+                <a:srgbClr val="002060"/>
+              </a:buClr>
+              <a:buSzPts val="2800"/>
+              <a:buNone/>
             </a:pPr>
             <a:r>
               <a:rPr lang="en-IN" sz="1400"/>
@@ -15729,21 +16764,21 @@
             <a:endParaRPr sz="1400"/>
           </a:p>
           <a:p>
-            <a:pPr marL="685800" lvl="1" indent="-228600" algn="l" rtl="0">
-              <a:lnSpc>
-                <a:spcPct val="90000"/>
-              </a:lnSpc>
-              <a:spcBef>
-                <a:spcPts val="500"/>
-              </a:spcBef>
-              <a:spcAft>
-                <a:spcPts val="0"/>
-              </a:spcAft>
-              <a:buClr>
-                <a:schemeClr val="dk1"/>
-              </a:buClr>
-              <a:buSzPct val="100000"/>
-              <a:buChar char="•"/>
+            <a:pPr marL="228600" lvl="0" indent="-50800" algn="l" rtl="0">
+              <a:lnSpc>
+                <a:spcPct val="90000"/>
+              </a:lnSpc>
+              <a:spcBef>
+                <a:spcPts val="1000"/>
+              </a:spcBef>
+              <a:spcAft>
+                <a:spcPts val="0"/>
+              </a:spcAft>
+              <a:buClr>
+                <a:srgbClr val="002060"/>
+              </a:buClr>
+              <a:buSzPts val="2800"/>
+              <a:buNone/>
             </a:pPr>
             <a:r>
               <a:rPr lang="en-IN" sz="1400"/>
@@ -15752,21 +16787,21 @@
             <a:endParaRPr sz="1400"/>
           </a:p>
           <a:p>
-            <a:pPr marL="685800" lvl="1" indent="-228600" algn="l" rtl="0">
-              <a:lnSpc>
-                <a:spcPct val="90000"/>
-              </a:lnSpc>
-              <a:spcBef>
-                <a:spcPts val="500"/>
-              </a:spcBef>
-              <a:spcAft>
-                <a:spcPts val="0"/>
-              </a:spcAft>
-              <a:buClr>
-                <a:schemeClr val="dk1"/>
-              </a:buClr>
-              <a:buSzPct val="100000"/>
-              <a:buChar char="•"/>
+            <a:pPr marL="228600" lvl="0" indent="-50800" algn="l" rtl="0">
+              <a:lnSpc>
+                <a:spcPct val="90000"/>
+              </a:lnSpc>
+              <a:spcBef>
+                <a:spcPts val="1000"/>
+              </a:spcBef>
+              <a:spcAft>
+                <a:spcPts val="0"/>
+              </a:spcAft>
+              <a:buClr>
+                <a:srgbClr val="002060"/>
+              </a:buClr>
+              <a:buSzPts val="2800"/>
+              <a:buNone/>
             </a:pPr>
             <a:r>
               <a:rPr lang="en-IN" sz="1400"/>
@@ -15870,7 +16905,7 @@
             </a:pPr>
             <a:fld id="{00000000-1234-1234-1234-123412341234}" type="slidenum">
               <a:rPr lang="en-IN"/>
-              <a:t>12</a:t>
+              <a:t>14</a:t>
             </a:fld>
             <a:endParaRPr/>
           </a:p>
@@ -15942,7 +16977,7 @@
 </p:sld>
 </file>
 
-<file path=ppt/slides/slide13.xml><?xml version="1.0" encoding="utf-8"?>
+<file path=ppt/slides/slide15.xml><?xml version="1.0" encoding="utf-8"?>
 <p:sld xmlns:a="http://schemas.openxmlformats.org/drawingml/2006/main" xmlns:r="http://schemas.openxmlformats.org/officeDocument/2006/relationships" xmlns:p="http://schemas.openxmlformats.org/presentationml/2006/main">
   <p:cSld>
     <p:spTree>
@@ -16011,21 +17046,21 @@
             <a:endParaRPr sz="1600"/>
           </a:p>
           <a:p>
-            <a:pPr marL="685800" lvl="1" indent="-228600" algn="l" rtl="0">
-              <a:lnSpc>
-                <a:spcPct val="90000"/>
-              </a:lnSpc>
-              <a:spcBef>
-                <a:spcPts val="500"/>
-              </a:spcBef>
-              <a:spcAft>
-                <a:spcPts val="0"/>
-              </a:spcAft>
-              <a:buClr>
-                <a:schemeClr val="dk1"/>
-              </a:buClr>
-              <a:buSzPct val="100000"/>
-              <a:buChar char="•"/>
+            <a:pPr marL="228600" lvl="0" indent="-50800" algn="l" rtl="0">
+              <a:lnSpc>
+                <a:spcPct val="90000"/>
+              </a:lnSpc>
+              <a:spcBef>
+                <a:spcPts val="1000"/>
+              </a:spcBef>
+              <a:spcAft>
+                <a:spcPts val="0"/>
+              </a:spcAft>
+              <a:buClr>
+                <a:srgbClr val="002060"/>
+              </a:buClr>
+              <a:buSzPts val="2800"/>
+              <a:buNone/>
             </a:pPr>
             <a:r>
               <a:rPr lang="en-IN" sz="1500"/>
@@ -16057,21 +17092,21 @@
             <a:endParaRPr sz="1600"/>
           </a:p>
           <a:p>
-            <a:pPr marL="685800" lvl="1" indent="-228600" algn="l" rtl="0">
-              <a:lnSpc>
-                <a:spcPct val="90000"/>
-              </a:lnSpc>
-              <a:spcBef>
-                <a:spcPts val="500"/>
-              </a:spcBef>
-              <a:spcAft>
-                <a:spcPts val="0"/>
-              </a:spcAft>
-              <a:buClr>
-                <a:schemeClr val="dk1"/>
-              </a:buClr>
-              <a:buSzPct val="100000"/>
-              <a:buChar char="•"/>
+            <a:pPr marL="228600" lvl="0" indent="-50800" algn="l" rtl="0">
+              <a:lnSpc>
+                <a:spcPct val="90000"/>
+              </a:lnSpc>
+              <a:spcBef>
+                <a:spcPts val="1000"/>
+              </a:spcBef>
+              <a:spcAft>
+                <a:spcPts val="0"/>
+              </a:spcAft>
+              <a:buClr>
+                <a:srgbClr val="002060"/>
+              </a:buClr>
+              <a:buSzPts val="2800"/>
+              <a:buNone/>
             </a:pPr>
             <a:r>
               <a:rPr lang="en-IN" sz="1500"/>
@@ -16103,21 +17138,21 @@
             <a:endParaRPr sz="1600"/>
           </a:p>
           <a:p>
-            <a:pPr marL="685800" lvl="1" indent="-228600" algn="l" rtl="0">
-              <a:lnSpc>
-                <a:spcPct val="90000"/>
-              </a:lnSpc>
-              <a:spcBef>
-                <a:spcPts val="500"/>
-              </a:spcBef>
-              <a:spcAft>
-                <a:spcPts val="0"/>
-              </a:spcAft>
-              <a:buClr>
-                <a:schemeClr val="dk1"/>
-              </a:buClr>
-              <a:buSzPct val="100000"/>
-              <a:buChar char="•"/>
+            <a:pPr marL="228600" lvl="0" indent="-50800" algn="l" rtl="0">
+              <a:lnSpc>
+                <a:spcPct val="90000"/>
+              </a:lnSpc>
+              <a:spcBef>
+                <a:spcPts val="1000"/>
+              </a:spcBef>
+              <a:spcAft>
+                <a:spcPts val="0"/>
+              </a:spcAft>
+              <a:buClr>
+                <a:srgbClr val="002060"/>
+              </a:buClr>
+              <a:buSzPts val="2800"/>
+              <a:buNone/>
             </a:pPr>
             <a:r>
               <a:rPr lang="en-IN" sz="1500"/>
@@ -16149,21 +17184,21 @@
             <a:endParaRPr sz="1600"/>
           </a:p>
           <a:p>
-            <a:pPr marL="685800" lvl="1" indent="-228600" algn="l" rtl="0">
-              <a:lnSpc>
-                <a:spcPct val="90000"/>
-              </a:lnSpc>
-              <a:spcBef>
-                <a:spcPts val="500"/>
-              </a:spcBef>
-              <a:spcAft>
-                <a:spcPts val="0"/>
-              </a:spcAft>
-              <a:buClr>
-                <a:schemeClr val="dk1"/>
-              </a:buClr>
-              <a:buSzPct val="100000"/>
-              <a:buChar char="•"/>
+            <a:pPr marL="228600" lvl="0" indent="-50800" algn="l" rtl="0">
+              <a:lnSpc>
+                <a:spcPct val="90000"/>
+              </a:lnSpc>
+              <a:spcBef>
+                <a:spcPts val="1000"/>
+              </a:spcBef>
+              <a:spcAft>
+                <a:spcPts val="0"/>
+              </a:spcAft>
+              <a:buClr>
+                <a:srgbClr val="002060"/>
+              </a:buClr>
+              <a:buSzPts val="2800"/>
+              <a:buNone/>
             </a:pPr>
             <a:r>
               <a:rPr lang="en-IN" sz="1500"/>
@@ -16195,21 +17230,21 @@
             <a:endParaRPr sz="1600"/>
           </a:p>
           <a:p>
-            <a:pPr marL="685800" lvl="1" indent="-228600" algn="l" rtl="0">
-              <a:lnSpc>
-                <a:spcPct val="90000"/>
-              </a:lnSpc>
-              <a:spcBef>
-                <a:spcPts val="500"/>
-              </a:spcBef>
-              <a:spcAft>
-                <a:spcPts val="0"/>
-              </a:spcAft>
-              <a:buClr>
-                <a:schemeClr val="dk1"/>
-              </a:buClr>
-              <a:buSzPct val="100000"/>
-              <a:buChar char="•"/>
+            <a:pPr marL="228600" lvl="0" indent="-50800" algn="l" rtl="0">
+              <a:lnSpc>
+                <a:spcPct val="90000"/>
+              </a:lnSpc>
+              <a:spcBef>
+                <a:spcPts val="1000"/>
+              </a:spcBef>
+              <a:spcAft>
+                <a:spcPts val="0"/>
+              </a:spcAft>
+              <a:buClr>
+                <a:srgbClr val="002060"/>
+              </a:buClr>
+              <a:buSzPts val="2800"/>
+              <a:buNone/>
             </a:pPr>
             <a:r>
               <a:rPr lang="en-IN" sz="1500"/>
@@ -16259,7 +17294,7 @@
             </a:pPr>
             <a:fld id="{00000000-1234-1234-1234-123412341234}" type="slidenum">
               <a:rPr lang="en-IN"/>
-              <a:t>13</a:t>
+              <a:t>15</a:t>
             </a:fld>
             <a:endParaRPr/>
           </a:p>
@@ -16331,7 +17366,7 @@
 </p:sld>
 </file>
 
-<file path=ppt/slides/slide14.xml><?xml version="1.0" encoding="utf-8"?>
+<file path=ppt/slides/slide16.xml><?xml version="1.0" encoding="utf-8"?>
 <p:sld xmlns:a="http://schemas.openxmlformats.org/drawingml/2006/main" xmlns:r="http://schemas.openxmlformats.org/officeDocument/2006/relationships" xmlns:p="http://schemas.openxmlformats.org/presentationml/2006/main">
   <p:cSld>
     <p:spTree>
@@ -16399,7 +17434,7 @@
             </a:r>
             <a:r>
               <a:rPr lang="en-IN" sz="1800"/>
-              <a:t>the complete fly brain runs on our laptop and we have already broken one behaviour by hand with 3 neurons. NeuroRedTeam turns that into a method: an attacker agent that finds the smallest change that breaks a behaviour, a defender agent that finds the smallest stimulation that repairs it, and a fragility atlas of the whole brain. Prior work perturbed the model by hand; nobody has automated the attack, built the repair, or produced the atlas.</a:t>
+              <a:t>the complete fly brain runs on our laptop and we have already broken one behaviour by hand with 3 neurons. NeuroRedTeam turns that into a method: an attacker agent that finds the smallest change that breaks a behaviour, a defender agent that finds the smallest stimulation that repairs it, and a fragility atlas of the whole brain. Prior work perturbed the model by hand; as far as we found, no one has automated the attack, built the repair, or produced such an atlas.</a:t>
             </a:r>
             <a:endParaRPr sz="1800"/>
           </a:p>
@@ -16499,7 +17534,7 @@
             </a:pPr>
             <a:fld id="{00000000-1234-1234-1234-123412341234}" type="slidenum">
               <a:rPr lang="en-IN"/>
-              <a:t>14</a:t>
+              <a:t>16</a:t>
             </a:fld>
             <a:endParaRPr/>
           </a:p>
@@ -16571,7 +17606,7 @@
 </p:sld>
 </file>
 
-<file path=ppt/slides/slide15.xml><?xml version="1.0" encoding="utf-8"?>
+<file path=ppt/slides/slide17.xml><?xml version="1.0" encoding="utf-8"?>
 <p:sld xmlns:a="http://schemas.openxmlformats.org/drawingml/2006/main" xmlns:r="http://schemas.openxmlformats.org/officeDocument/2006/relationships" xmlns:p="http://schemas.openxmlformats.org/presentationml/2006/main">
   <p:cSld>
     <p:spTree>
@@ -16842,7 +17877,7 @@
             </a:pPr>
             <a:fld id="{00000000-1234-1234-1234-123412341234}" type="slidenum">
               <a:rPr lang="en-IN"/>
-              <a:t>15</a:t>
+              <a:t>17</a:t>
             </a:fld>
             <a:endParaRPr/>
           </a:p>
@@ -16914,7 +17949,7 @@
 </p:sld>
 </file>
 
-<file path=ppt/slides/slide16.xml><?xml version="1.0" encoding="utf-8"?>
+<file path=ppt/slides/slide18.xml><?xml version="1.0" encoding="utf-8"?>
 <p:sld xmlns:a="http://schemas.openxmlformats.org/drawingml/2006/main" xmlns:r="http://schemas.openxmlformats.org/officeDocument/2006/relationships" xmlns:p="http://schemas.openxmlformats.org/presentationml/2006/main">
   <p:cSld>
     <p:spTree>
@@ -17208,7 +18243,7 @@
             </a:pPr>
             <a:fld id="{00000000-1234-1234-1234-123412341234}" type="slidenum">
               <a:rPr lang="en-IN"/>
-              <a:t>16</a:t>
+              <a:t>18</a:t>
             </a:fld>
             <a:endParaRPr/>
           </a:p>
@@ -17280,7 +18315,7 @@
 </p:sld>
 </file>
 
-<file path=ppt/slides/slide17.xml><?xml version="1.0" encoding="utf-8"?>
+<file path=ppt/slides/slide19.xml><?xml version="1.0" encoding="utf-8"?>
 <p:sld xmlns:a="http://schemas.openxmlformats.org/drawingml/2006/main" xmlns:r="http://schemas.openxmlformats.org/officeDocument/2006/relationships" xmlns:p="http://schemas.openxmlformats.org/presentationml/2006/main">
   <p:cSld>
     <p:spTree>
@@ -17548,7 +18583,7 @@
             </a:pPr>
             <a:fld id="{00000000-1234-1234-1234-123412341234}" type="slidenum">
               <a:rPr lang="en-IN"/>
-              <a:t>17</a:t>
+              <a:t>19</a:t>
             </a:fld>
             <a:endParaRPr/>
           </a:p>
@@ -17612,104 +18647,6 @@
           </a:p>
         </p:txBody>
       </p:sp>
-    </p:spTree>
-  </p:cSld>
-  <p:clrMapOvr>
-    <a:masterClrMapping/>
-  </p:clrMapOvr>
-</p:sld>
-</file>
-
-<file path=ppt/slides/slide18.xml><?xml version="1.0" encoding="utf-8"?>
-<p:sld xmlns:a="http://schemas.openxmlformats.org/drawingml/2006/main" xmlns:r="http://schemas.openxmlformats.org/officeDocument/2006/relationships" xmlns:p="http://schemas.openxmlformats.org/presentationml/2006/main">
-  <p:cSld>
-    <p:spTree>
-      <p:nvGrpSpPr>
-        <p:cNvPr id="1" name="Shape 240"/>
-        <p:cNvGrpSpPr/>
-        <p:nvPr/>
-      </p:nvGrpSpPr>
-      <p:grpSpPr>
-        <a:xfrm>
-          <a:off x="0" y="0"/>
-          <a:ext cx="0" cy="0"/>
-          <a:chOff x="0" y="0"/>
-          <a:chExt cx="0" cy="0"/>
-        </a:xfrm>
-      </p:grpSpPr>
-      <p:sp>
-        <p:nvSpPr>
-          <p:cNvPr id="242" name="Google Shape;242;p16"/>
-          <p:cNvSpPr txBox="1">
-            <a:spLocks noGrp="1"/>
-          </p:cNvSpPr>
-          <p:nvPr>
-            <p:ph type="sldNum" idx="12"/>
-          </p:nvPr>
-        </p:nvSpPr>
-        <p:spPr>
-          <a:xfrm>
-            <a:off x="9273988" y="6347205"/>
-            <a:ext cx="2743200" cy="365125"/>
-          </a:xfrm>
-          <a:prstGeom prst="rect">
-            <a:avLst/>
-          </a:prstGeom>
-          <a:noFill/>
-          <a:ln>
-            <a:noFill/>
-          </a:ln>
-        </p:spPr>
-        <p:txBody>
-          <a:bodyPr spcFirstLastPara="1" wrap="square" lIns="91425" tIns="45700" rIns="91425" bIns="45700" anchor="ctr" anchorCtr="0">
-            <a:noAutofit/>
-          </a:bodyPr>
-          <a:lstStyle/>
-          <a:p>
-            <a:pPr marL="0" lvl="0" indent="0" algn="r" rtl="0">
-              <a:spcBef>
-                <a:spcPts val="0"/>
-              </a:spcBef>
-              <a:spcAft>
-                <a:spcPts val="0"/>
-              </a:spcAft>
-              <a:buNone/>
-            </a:pPr>
-            <a:fld id="{00000000-1234-1234-1234-123412341234}" type="slidenum">
-              <a:rPr lang="en-IN"/>
-              <a:t>18</a:t>
-            </a:fld>
-            <a:endParaRPr/>
-          </a:p>
-        </p:txBody>
-      </p:sp>
-      <p:pic>
-        <p:nvPicPr>
-          <p:cNvPr id="243" name="Google Shape;243;p16"/>
-          <p:cNvPicPr preferRelativeResize="0"/>
-          <p:nvPr/>
-        </p:nvPicPr>
-        <p:blipFill rotWithShape="1">
-          <a:blip r:embed="rId3">
-            <a:alphaModFix/>
-          </a:blip>
-          <a:srcRect/>
-          <a:stretch/>
-        </p:blipFill>
-        <p:spPr>
-          <a:xfrm>
-            <a:off x="3151096" y="1605964"/>
-            <a:ext cx="5889812" cy="3646074"/>
-          </a:xfrm>
-          <a:prstGeom prst="rect">
-            <a:avLst/>
-          </a:prstGeom>
-          <a:noFill/>
-          <a:ln>
-            <a:noFill/>
-          </a:ln>
-        </p:spPr>
-      </p:pic>
     </p:spTree>
   </p:cSld>
   <p:clrMapOvr>
@@ -17809,6 +18746,104 @@
           </a:p>
         </p:txBody>
       </p:sp>
+    </p:spTree>
+  </p:cSld>
+  <p:clrMapOvr>
+    <a:masterClrMapping/>
+  </p:clrMapOvr>
+</p:sld>
+</file>
+
+<file path=ppt/slides/slide20.xml><?xml version="1.0" encoding="utf-8"?>
+<p:sld xmlns:a="http://schemas.openxmlformats.org/drawingml/2006/main" xmlns:r="http://schemas.openxmlformats.org/officeDocument/2006/relationships" xmlns:p="http://schemas.openxmlformats.org/presentationml/2006/main">
+  <p:cSld>
+    <p:spTree>
+      <p:nvGrpSpPr>
+        <p:cNvPr id="1" name="Shape 240"/>
+        <p:cNvGrpSpPr/>
+        <p:nvPr/>
+      </p:nvGrpSpPr>
+      <p:grpSpPr>
+        <a:xfrm>
+          <a:off x="0" y="0"/>
+          <a:ext cx="0" cy="0"/>
+          <a:chOff x="0" y="0"/>
+          <a:chExt cx="0" cy="0"/>
+        </a:xfrm>
+      </p:grpSpPr>
+      <p:sp>
+        <p:nvSpPr>
+          <p:cNvPr id="242" name="Google Shape;242;p16"/>
+          <p:cNvSpPr txBox="1">
+            <a:spLocks noGrp="1"/>
+          </p:cNvSpPr>
+          <p:nvPr>
+            <p:ph type="sldNum" idx="12"/>
+          </p:nvPr>
+        </p:nvSpPr>
+        <p:spPr>
+          <a:xfrm>
+            <a:off x="9273988" y="6347205"/>
+            <a:ext cx="2743200" cy="365125"/>
+          </a:xfrm>
+          <a:prstGeom prst="rect">
+            <a:avLst/>
+          </a:prstGeom>
+          <a:noFill/>
+          <a:ln>
+            <a:noFill/>
+          </a:ln>
+        </p:spPr>
+        <p:txBody>
+          <a:bodyPr spcFirstLastPara="1" wrap="square" lIns="91425" tIns="45700" rIns="91425" bIns="45700" anchor="ctr" anchorCtr="0">
+            <a:noAutofit/>
+          </a:bodyPr>
+          <a:lstStyle/>
+          <a:p>
+            <a:pPr marL="0" lvl="0" indent="0" algn="r" rtl="0">
+              <a:spcBef>
+                <a:spcPts val="0"/>
+              </a:spcBef>
+              <a:spcAft>
+                <a:spcPts val="0"/>
+              </a:spcAft>
+              <a:buNone/>
+            </a:pPr>
+            <a:fld id="{00000000-1234-1234-1234-123412341234}" type="slidenum">
+              <a:rPr lang="en-IN"/>
+              <a:t>20</a:t>
+            </a:fld>
+            <a:endParaRPr/>
+          </a:p>
+        </p:txBody>
+      </p:sp>
+      <p:pic>
+        <p:nvPicPr>
+          <p:cNvPr id="243" name="Google Shape;243;p16"/>
+          <p:cNvPicPr preferRelativeResize="0"/>
+          <p:nvPr/>
+        </p:nvPicPr>
+        <p:blipFill rotWithShape="1">
+          <a:blip r:embed="rId3">
+            <a:alphaModFix/>
+          </a:blip>
+          <a:srcRect/>
+          <a:stretch/>
+        </p:blipFill>
+        <p:spPr>
+          <a:xfrm>
+            <a:off x="3151096" y="1605964"/>
+            <a:ext cx="5889812" cy="3646074"/>
+          </a:xfrm>
+          <a:prstGeom prst="rect">
+            <a:avLst/>
+          </a:prstGeom>
+          <a:noFill/>
+          <a:ln>
+            <a:noFill/>
+          </a:ln>
+        </p:spPr>
+      </p:pic>
     </p:spTree>
   </p:cSld>
   <p:clrMapOvr>
@@ -18679,21 +19714,21 @@
             <a:endParaRPr sz="1400"/>
           </a:p>
           <a:p>
-            <a:pPr marL="685800" lvl="1" indent="-228600" algn="l" rtl="0">
-              <a:lnSpc>
-                <a:spcPct val="90000"/>
-              </a:lnSpc>
-              <a:spcBef>
-                <a:spcPts val="500"/>
-              </a:spcBef>
-              <a:spcAft>
-                <a:spcPts val="0"/>
-              </a:spcAft>
-              <a:buClr>
-                <a:schemeClr val="dk1"/>
-              </a:buClr>
-              <a:buSzPct val="100000"/>
-              <a:buChar char="•"/>
+            <a:pPr marL="228600" lvl="0" indent="-50800" algn="l" rtl="0">
+              <a:lnSpc>
+                <a:spcPct val="90000"/>
+              </a:lnSpc>
+              <a:spcBef>
+                <a:spcPts val="1000"/>
+              </a:spcBef>
+              <a:spcAft>
+                <a:spcPts val="0"/>
+              </a:spcAft>
+              <a:buClr>
+                <a:srgbClr val="002060"/>
+              </a:buClr>
+              <a:buSzPts val="2800"/>
+              <a:buNone/>
             </a:pPr>
             <a:r>
               <a:rPr lang="en-IN" sz="1300" b="1"/>
@@ -18706,21 +19741,21 @@
             <a:endParaRPr sz="1300"/>
           </a:p>
           <a:p>
-            <a:pPr marL="685800" lvl="1" indent="-228600" algn="l" rtl="0">
-              <a:lnSpc>
-                <a:spcPct val="90000"/>
-              </a:lnSpc>
-              <a:spcBef>
-                <a:spcPts val="500"/>
-              </a:spcBef>
-              <a:spcAft>
-                <a:spcPts val="0"/>
-              </a:spcAft>
-              <a:buClr>
-                <a:schemeClr val="dk1"/>
-              </a:buClr>
-              <a:buSzPct val="100000"/>
-              <a:buChar char="•"/>
+            <a:pPr marL="228600" lvl="0" indent="-50800" algn="l" rtl="0">
+              <a:lnSpc>
+                <a:spcPct val="90000"/>
+              </a:lnSpc>
+              <a:spcBef>
+                <a:spcPts val="1000"/>
+              </a:spcBef>
+              <a:spcAft>
+                <a:spcPts val="0"/>
+              </a:spcAft>
+              <a:buClr>
+                <a:srgbClr val="002060"/>
+              </a:buClr>
+              <a:buSzPts val="2800"/>
+              <a:buNone/>
             </a:pPr>
             <a:r>
               <a:rPr lang="en-IN" sz="1300" b="1"/>
@@ -18756,21 +19791,21 @@
             <a:endParaRPr sz="1400"/>
           </a:p>
           <a:p>
-            <a:pPr marL="685800" lvl="1" indent="-228600" algn="l" rtl="0">
-              <a:lnSpc>
-                <a:spcPct val="90000"/>
-              </a:lnSpc>
-              <a:spcBef>
-                <a:spcPts val="500"/>
-              </a:spcBef>
-              <a:spcAft>
-                <a:spcPts val="0"/>
-              </a:spcAft>
-              <a:buClr>
-                <a:schemeClr val="dk1"/>
-              </a:buClr>
-              <a:buSzPct val="100000"/>
-              <a:buChar char="•"/>
+            <a:pPr marL="228600" lvl="0" indent="-50800" algn="l" rtl="0">
+              <a:lnSpc>
+                <a:spcPct val="90000"/>
+              </a:lnSpc>
+              <a:spcBef>
+                <a:spcPts val="1000"/>
+              </a:spcBef>
+              <a:spcAft>
+                <a:spcPts val="0"/>
+              </a:spcAft>
+              <a:buClr>
+                <a:srgbClr val="002060"/>
+              </a:buClr>
+              <a:buSzPts val="2800"/>
+              <a:buNone/>
             </a:pPr>
             <a:r>
               <a:rPr lang="en-IN" sz="1300" b="1"/>
@@ -18783,21 +19818,21 @@
             <a:endParaRPr sz="1300"/>
           </a:p>
           <a:p>
-            <a:pPr marL="685800" lvl="1" indent="-228600" algn="l" rtl="0">
-              <a:lnSpc>
-                <a:spcPct val="90000"/>
-              </a:lnSpc>
-              <a:spcBef>
-                <a:spcPts val="500"/>
-              </a:spcBef>
-              <a:spcAft>
-                <a:spcPts val="0"/>
-              </a:spcAft>
-              <a:buClr>
-                <a:schemeClr val="dk1"/>
-              </a:buClr>
-              <a:buSzPct val="100000"/>
-              <a:buChar char="•"/>
+            <a:pPr marL="228600" lvl="0" indent="-50800" algn="l" rtl="0">
+              <a:lnSpc>
+                <a:spcPct val="90000"/>
+              </a:lnSpc>
+              <a:spcBef>
+                <a:spcPts val="1000"/>
+              </a:spcBef>
+              <a:spcAft>
+                <a:spcPts val="0"/>
+              </a:spcAft>
+              <a:buClr>
+                <a:srgbClr val="002060"/>
+              </a:buClr>
+              <a:buSzPts val="2800"/>
+              <a:buNone/>
             </a:pPr>
             <a:r>
               <a:rPr lang="en-IN" sz="1300" b="1"/>
@@ -18810,21 +19845,21 @@
             <a:endParaRPr sz="1300"/>
           </a:p>
           <a:p>
-            <a:pPr marL="685800" lvl="1" indent="-228600" algn="l" rtl="0">
-              <a:lnSpc>
-                <a:spcPct val="90000"/>
-              </a:lnSpc>
-              <a:spcBef>
-                <a:spcPts val="500"/>
-              </a:spcBef>
-              <a:spcAft>
-                <a:spcPts val="0"/>
-              </a:spcAft>
-              <a:buClr>
-                <a:schemeClr val="dk1"/>
-              </a:buClr>
-              <a:buSzPct val="100000"/>
-              <a:buChar char="•"/>
+            <a:pPr marL="228600" lvl="0" indent="-50800" algn="l" rtl="0">
+              <a:lnSpc>
+                <a:spcPct val="90000"/>
+              </a:lnSpc>
+              <a:spcBef>
+                <a:spcPts val="1000"/>
+              </a:spcBef>
+              <a:spcAft>
+                <a:spcPts val="0"/>
+              </a:spcAft>
+              <a:buClr>
+                <a:srgbClr val="002060"/>
+              </a:buClr>
+              <a:buSzPts val="2800"/>
+              <a:buNone/>
             </a:pPr>
             <a:r>
               <a:rPr lang="en-IN" sz="1300" b="1"/>
@@ -18882,11 +19917,11 @@
             </a:pPr>
             <a:r>
               <a:rPr lang="en-IN" sz="1400" b="1"/>
-              <a:t xml:space="preserve">Gap: </a:t>
+              <a:t xml:space="preserve">Gap (as far as we could find): </a:t>
             </a:r>
             <a:r>
               <a:rPr lang="en-IN" sz="1400"/>
-              <a:t>nobody has automatically searched a whole-brain behavioural simulation for the smallest change that breaks a behaviour, nobody has designed the smallest stimulation that repairs it, and there is no table of how fragile each fly behaviour is.</a:t>
+              <a:t>no automated search of a whole-brain behavioural simulation for the smallest change that breaks a behaviour, no automated design of the smallest stimulation that repairs it, and no table of how fragile each fly behaviour is.</a:t>
             </a:r>
             <a:endParaRPr sz="1400"/>
           </a:p>
@@ -19344,21 +20379,21 @@
             <a:endParaRPr sz="1500"/>
           </a:p>
           <a:p>
-            <a:pPr marL="685800" lvl="1" indent="-228600" algn="l" rtl="0">
-              <a:lnSpc>
-                <a:spcPct val="90000"/>
-              </a:lnSpc>
-              <a:spcBef>
-                <a:spcPts val="500"/>
-              </a:spcBef>
-              <a:spcAft>
-                <a:spcPts val="0"/>
-              </a:spcAft>
-              <a:buClr>
-                <a:schemeClr val="dk1"/>
-              </a:buClr>
-              <a:buSzPct val="100000"/>
-              <a:buChar char="•"/>
+            <a:pPr marL="228600" lvl="0" indent="-50800" algn="l" rtl="0">
+              <a:lnSpc>
+                <a:spcPct val="90000"/>
+              </a:lnSpc>
+              <a:spcBef>
+                <a:spcPts val="1000"/>
+              </a:spcBef>
+              <a:spcAft>
+                <a:spcPts val="0"/>
+              </a:spcAft>
+              <a:buClr>
+                <a:srgbClr val="002060"/>
+              </a:buClr>
+              <a:buSzPts val="2800"/>
+              <a:buNone/>
             </a:pPr>
             <a:r>
               <a:rPr lang="en-IN" sz="1400" b="1"/>
@@ -19371,21 +20406,21 @@
             <a:endParaRPr sz="1400"/>
           </a:p>
           <a:p>
-            <a:pPr marL="685800" lvl="1" indent="-228600" algn="l" rtl="0">
-              <a:lnSpc>
-                <a:spcPct val="90000"/>
-              </a:lnSpc>
-              <a:spcBef>
-                <a:spcPts val="500"/>
-              </a:spcBef>
-              <a:spcAft>
-                <a:spcPts val="0"/>
-              </a:spcAft>
-              <a:buClr>
-                <a:schemeClr val="dk1"/>
-              </a:buClr>
-              <a:buSzPct val="100000"/>
-              <a:buChar char="•"/>
+            <a:pPr marL="228600" lvl="0" indent="-50800" algn="l" rtl="0">
+              <a:lnSpc>
+                <a:spcPct val="90000"/>
+              </a:lnSpc>
+              <a:spcBef>
+                <a:spcPts val="1000"/>
+              </a:spcBef>
+              <a:spcAft>
+                <a:spcPts val="0"/>
+              </a:spcAft>
+              <a:buClr>
+                <a:srgbClr val="002060"/>
+              </a:buClr>
+              <a:buSzPts val="2800"/>
+              <a:buNone/>
             </a:pPr>
             <a:r>
               <a:rPr lang="en-IN" sz="1400" b="1"/>
@@ -19398,21 +20433,21 @@
             <a:endParaRPr sz="1400"/>
           </a:p>
           <a:p>
-            <a:pPr marL="685800" lvl="1" indent="-228600" algn="l" rtl="0">
-              <a:lnSpc>
-                <a:spcPct val="90000"/>
-              </a:lnSpc>
-              <a:spcBef>
-                <a:spcPts val="500"/>
-              </a:spcBef>
-              <a:spcAft>
-                <a:spcPts val="0"/>
-              </a:spcAft>
-              <a:buClr>
-                <a:schemeClr val="dk1"/>
-              </a:buClr>
-              <a:buSzPct val="100000"/>
-              <a:buChar char="•"/>
+            <a:pPr marL="228600" lvl="0" indent="-50800" algn="l" rtl="0">
+              <a:lnSpc>
+                <a:spcPct val="90000"/>
+              </a:lnSpc>
+              <a:spcBef>
+                <a:spcPts val="1000"/>
+              </a:spcBef>
+              <a:spcAft>
+                <a:spcPts val="0"/>
+              </a:spcAft>
+              <a:buClr>
+                <a:srgbClr val="002060"/>
+              </a:buClr>
+              <a:buSzPts val="2800"/>
+              <a:buNone/>
             </a:pPr>
             <a:r>
               <a:rPr lang="en-IN" sz="1400" b="1"/>
@@ -19425,21 +20460,21 @@
             <a:endParaRPr sz="1400"/>
           </a:p>
           <a:p>
-            <a:pPr marL="685800" lvl="1" indent="-228600" algn="l" rtl="0">
-              <a:lnSpc>
-                <a:spcPct val="90000"/>
-              </a:lnSpc>
-              <a:spcBef>
-                <a:spcPts val="500"/>
-              </a:spcBef>
-              <a:spcAft>
-                <a:spcPts val="0"/>
-              </a:spcAft>
-              <a:buClr>
-                <a:schemeClr val="dk1"/>
-              </a:buClr>
-              <a:buSzPct val="100000"/>
-              <a:buChar char="•"/>
+            <a:pPr marL="228600" lvl="0" indent="-50800" algn="l" rtl="0">
+              <a:lnSpc>
+                <a:spcPct val="90000"/>
+              </a:lnSpc>
+              <a:spcBef>
+                <a:spcPts val="1000"/>
+              </a:spcBef>
+              <a:spcAft>
+                <a:spcPts val="0"/>
+              </a:spcAft>
+              <a:buClr>
+                <a:srgbClr val="002060"/>
+              </a:buClr>
+              <a:buSzPts val="2800"/>
+              <a:buNone/>
             </a:pPr>
             <a:r>
               <a:rPr lang="en-IN" sz="1400" b="1"/>
@@ -19452,21 +20487,21 @@
             <a:endParaRPr sz="1400"/>
           </a:p>
           <a:p>
-            <a:pPr marL="685800" lvl="1" indent="-228600" algn="l" rtl="0">
-              <a:lnSpc>
-                <a:spcPct val="90000"/>
-              </a:lnSpc>
-              <a:spcBef>
-                <a:spcPts val="500"/>
-              </a:spcBef>
-              <a:spcAft>
-                <a:spcPts val="0"/>
-              </a:spcAft>
-              <a:buClr>
-                <a:schemeClr val="dk1"/>
-              </a:buClr>
-              <a:buSzPct val="100000"/>
-              <a:buChar char="•"/>
+            <a:pPr marL="228600" lvl="0" indent="-50800" algn="l" rtl="0">
+              <a:lnSpc>
+                <a:spcPct val="90000"/>
+              </a:lnSpc>
+              <a:spcBef>
+                <a:spcPts val="1000"/>
+              </a:spcBef>
+              <a:spcAft>
+                <a:spcPts val="0"/>
+              </a:spcAft>
+              <a:buClr>
+                <a:srgbClr val="002060"/>
+              </a:buClr>
+              <a:buSzPts val="2800"/>
+              <a:buNone/>
             </a:pPr>
             <a:r>
               <a:rPr lang="en-IN" sz="1400" b="1"/>
@@ -19479,21 +20514,21 @@
             <a:endParaRPr sz="1400"/>
           </a:p>
           <a:p>
-            <a:pPr marL="685800" lvl="1" indent="-228600" algn="l" rtl="0">
-              <a:lnSpc>
-                <a:spcPct val="90000"/>
-              </a:lnSpc>
-              <a:spcBef>
-                <a:spcPts val="500"/>
-              </a:spcBef>
-              <a:spcAft>
-                <a:spcPts val="0"/>
-              </a:spcAft>
-              <a:buClr>
-                <a:schemeClr val="dk1"/>
-              </a:buClr>
-              <a:buSzPct val="100000"/>
-              <a:buChar char="•"/>
+            <a:pPr marL="228600" lvl="0" indent="-50800" algn="l" rtl="0">
+              <a:lnSpc>
+                <a:spcPct val="90000"/>
+              </a:lnSpc>
+              <a:spcBef>
+                <a:spcPts val="1000"/>
+              </a:spcBef>
+              <a:spcAft>
+                <a:spcPts val="0"/>
+              </a:spcAft>
+              <a:buClr>
+                <a:srgbClr val="002060"/>
+              </a:buClr>
+              <a:buSzPts val="2800"/>
+              <a:buNone/>
             </a:pPr>
             <a:r>
               <a:rPr lang="en-IN" sz="1400" b="1"/>
@@ -19524,11 +20559,11 @@
             </a:pPr>
             <a:r>
               <a:rPr lang="en-IN" sz="1500" b="1"/>
-              <a:t xml:space="preserve">What is new: </a:t>
+              <a:t xml:space="preserve">What we believe is new (to the best of our literature search): </a:t>
             </a:r>
             <a:r>
               <a:rPr lang="en-IN" sz="1500"/>
-              <a:t>the automated minimal attack search, the defender, and the atlas. The simulator and virtual fly are our platform, reproduced from published work, not claimed as new.</a:t>
+              <a:t>the automated search for minimal attacks, the repair agent, and the fragility atlas. The simulator and virtual fly are our platform, reproduced from published work, and we do not claim them as new.</a:t>
             </a:r>
             <a:endParaRPr sz="1500"/>
           </a:p>

</xml_diff>